<commit_message>
feat: warehouse location scoping, permission copy, and a large backlog of MES feature work
Adds server-side enforcement so warehouse operations are restricted to the
correct physical location (Kho công ty vs Kho phân xưởng) via a new
scope_warehouse dimension, plus an admin-only feature to copy one user's full
permission/scope profile onto another. Syncs architecture/feature docs
(md/docx/pptx) to describe both, including an updated revision date.

Also commits the large backlog of previously-staged feature work accumulated
across this session (brew/filter/ferment orders, WMS unit tracking, QC stage
groups, warehouse requests, energy/SCADA integration, load slips, lot lock,
dashboard, and associated migrations/tests/docs) that had not yet been
committed.

Co-Authored-By: Claude Sonnet 5 <noreply@anthropic.com>
</commit_message>
<xml_diff>
--- a/docs/MES-KienTruc.pptx
+++ b/docs/MES-KienTruc.pptx
@@ -4067,7 +4067,7 @@
                 </a:solidFill>
                 <a:latin typeface="Calibri"/>
               </a:rPr>
-              <a:t>Edge &amp; Historian</a:t>
+              <a:t>CSDL SCADA thật (mới)</a:t>
             </a:r>
           </a:p>
         </p:txBody>
@@ -4109,7 +4109,7 @@
                 </a:solidFill>
                 <a:latin typeface="Calibri"/>
               </a:rPr>
-              <a:t>Tag UNS brewery/site/area/</a:t>
+              <a:t>Kết nối SQL Server ngoài</a:t>
             </a:r>
           </a:p>
           <a:p>
@@ -4128,7 +4128,7 @@
                 </a:solidFill>
                 <a:latin typeface="Calibri"/>
               </a:rPr>
-              <a:t>   device/metric</a:t>
+              <a:t>   (WinCC…), chỉ SELECT</a:t>
             </a:r>
           </a:p>
           <a:p>
@@ -4147,7 +4147,7 @@
                 </a:solidFill>
                 <a:latin typeface="Calibri"/>
               </a:rPr>
-              <a:t>ingest qua X-API-Key write</a:t>
+              <a:t>1 kết nối nhiều purpose</a:t>
             </a:r>
           </a:p>
           <a:p>
@@ -4166,7 +4166,7 @@
                 </a:solidFill>
                 <a:latin typeface="Calibri"/>
               </a:rPr>
-              <a:t>downsample min/avg/max</a:t>
+              <a:t>Panel Realtime 30K/nước thải</a:t>
             </a:r>
           </a:p>
           <a:p>
@@ -4185,7 +4185,7 @@
                 </a:solidFill>
                 <a:latin typeface="Calibri"/>
               </a:rPr>
-              <a:t>edge_sim mô phỏng gateway</a:t>
+              <a:t>tự làm mới 15s + tự thử lại</a:t>
             </a:r>
           </a:p>
           <a:p>
@@ -4204,26 +4204,7 @@
                 </a:solidFill>
                 <a:latin typeface="Calibri"/>
               </a:rPr>
-              <a:t>opcua_edge: client OPC UA</a:t>
-            </a:r>
-          </a:p>
-          <a:p>
-            <a:pPr algn="l">
-              <a:lnSpc>
-                <a:spcPct val="106000"/>
-              </a:lnSpc>
-              <a:spcAft>
-                <a:spcPts val="200"/>
-              </a:spcAft>
-            </a:pPr>
-            <a:r>
-              <a:rPr sz="1250" b="0" i="0">
-                <a:solidFill>
-                  <a:srgbClr val="222A3A"/>
-                </a:solidFill>
-                <a:latin typeface="Calibri"/>
-              </a:rPr>
-              <a:t>   thật (Weihenstephan)</a:t>
+              <a:t>kết nối lỗi mỗi 15s</a:t>
             </a:r>
           </a:p>
         </p:txBody>
@@ -7234,7 +7215,7 @@
                 </a:solidFill>
                 <a:latin typeface="Calibri"/>
               </a:rPr>
-              <a:t>GitHub Actions: ruff + pytest (30/30) + docker build</a:t>
+              <a:t>GitHub Actions: ruff + pytest (57 file test) + docker build</a:t>
             </a:r>
           </a:p>
         </p:txBody>
@@ -7393,8 +7374,8 @@
         </p:nvSpPr>
         <p:spPr>
           <a:xfrm>
-            <a:off x="548640" y="1645920"/>
-            <a:ext cx="457200" cy="457200"/>
+            <a:off x="548640" y="1536192"/>
+            <a:ext cx="420624" cy="420624"/>
           </a:xfrm>
           <a:prstGeom prst="ellipse">
             <a:avLst/>
@@ -7427,7 +7408,7 @@
           <a:p>
             <a:pPr algn="ctr"/>
             <a:r>
-              <a:rPr sz="1600" b="1">
+              <a:rPr sz="1500" b="1">
                 <a:solidFill>
                   <a:srgbClr val="1E2761"/>
                 </a:solidFill>
@@ -7446,8 +7427,8 @@
         </p:nvSpPr>
         <p:spPr>
           <a:xfrm>
-            <a:off x="1188720" y="1645920"/>
-            <a:ext cx="10424160" cy="603504"/>
+            <a:off x="1188720" y="1536192"/>
+            <a:ext cx="10424160" cy="548640"/>
           </a:xfrm>
           <a:prstGeom prst="roundRect">
             <a:avLst/>
@@ -7492,8 +7473,8 @@
         </p:nvSpPr>
         <p:spPr>
           <a:xfrm>
-            <a:off x="1417320" y="1645920"/>
-            <a:ext cx="10058400" cy="603504"/>
+            <a:off x="1417320" y="1536192"/>
+            <a:ext cx="10058400" cy="548640"/>
           </a:xfrm>
           <a:prstGeom prst="rect">
             <a:avLst/>
@@ -7515,13 +7496,13 @@
               </a:spcAft>
             </a:pPr>
             <a:r>
-              <a:rPr sz="1200" b="0" i="0">
+              <a:rPr sz="1150" b="0" i="0">
                 <a:solidFill>
                   <a:srgbClr val="222A3A"/>
                 </a:solidFill>
                 <a:latin typeface="Calibri"/>
               </a:rPr>
-              <a:t>Tích hợp thiết bị OT chạy ở dạng mô phỏng edge + client OPC UA demo — production cần trỏ PLC/SCADA thật</a:t>
+              <a:t>Panel Realtime đã đọc CSDL SCADA THẬT qua WAN (không còn mô phỏng) — mới nối 2 nguồn (30K, nước thải)</a:t>
             </a:r>
           </a:p>
         </p:txBody>
@@ -7534,8 +7515,8 @@
         </p:nvSpPr>
         <p:spPr>
           <a:xfrm>
-            <a:off x="548640" y="2395728"/>
-            <a:ext cx="457200" cy="457200"/>
+            <a:off x="548640" y="2194560"/>
+            <a:ext cx="420624" cy="420624"/>
           </a:xfrm>
           <a:prstGeom prst="ellipse">
             <a:avLst/>
@@ -7568,7 +7549,7 @@
           <a:p>
             <a:pPr algn="ctr"/>
             <a:r>
-              <a:rPr sz="1600" b="1">
+              <a:rPr sz="1500" b="1">
                 <a:solidFill>
                   <a:srgbClr val="1E2761"/>
                 </a:solidFill>
@@ -7587,8 +7568,8 @@
         </p:nvSpPr>
         <p:spPr>
           <a:xfrm>
-            <a:off x="1188720" y="2395728"/>
-            <a:ext cx="10424160" cy="603504"/>
+            <a:off x="1188720" y="2194560"/>
+            <a:ext cx="10424160" cy="548640"/>
           </a:xfrm>
           <a:prstGeom prst="roundRect">
             <a:avLst/>
@@ -7633,8 +7614,8 @@
         </p:nvSpPr>
         <p:spPr>
           <a:xfrm>
-            <a:off x="1417320" y="2395728"/>
-            <a:ext cx="10058400" cy="603504"/>
+            <a:off x="1417320" y="2194560"/>
+            <a:ext cx="10058400" cy="548640"/>
           </a:xfrm>
           <a:prstGeom prst="rect">
             <a:avLst/>
@@ -7656,13 +7637,13 @@
               </a:spcAft>
             </a:pPr>
             <a:r>
-              <a:rPr sz="1200" b="0" i="0">
+              <a:rPr sz="1150" b="0" i="0">
                 <a:solidFill>
                   <a:srgbClr val="222A3A"/>
                 </a:solidFill>
                 <a:latin typeface="Calibri"/>
               </a:rPr>
-              <a:t>Historian dùng SQLite; production swap TimescaleDB/InfluxDB (điểm cắm đã sẵn)</a:t>
+              <a:t>Historian nội bộ (edge OT demo) vẫn mô phỏng — production swap TimescaleDB/InfluxDB (điểm cắm đã sẵn)</a:t>
             </a:r>
           </a:p>
         </p:txBody>
@@ -7675,8 +7656,8 @@
         </p:nvSpPr>
         <p:spPr>
           <a:xfrm>
-            <a:off x="548640" y="3145536"/>
-            <a:ext cx="457200" cy="457200"/>
+            <a:off x="548640" y="2852928"/>
+            <a:ext cx="420624" cy="420624"/>
           </a:xfrm>
           <a:prstGeom prst="ellipse">
             <a:avLst/>
@@ -7709,7 +7690,7 @@
           <a:p>
             <a:pPr algn="ctr"/>
             <a:r>
-              <a:rPr sz="1600" b="1">
+              <a:rPr sz="1500" b="1">
                 <a:solidFill>
                   <a:srgbClr val="1E2761"/>
                 </a:solidFill>
@@ -7728,8 +7709,8 @@
         </p:nvSpPr>
         <p:spPr>
           <a:xfrm>
-            <a:off x="1188720" y="3145536"/>
-            <a:ext cx="10424160" cy="603504"/>
+            <a:off x="1188720" y="2852928"/>
+            <a:ext cx="10424160" cy="548640"/>
           </a:xfrm>
           <a:prstGeom prst="roundRect">
             <a:avLst/>
@@ -7774,8 +7755,8 @@
         </p:nvSpPr>
         <p:spPr>
           <a:xfrm>
-            <a:off x="1417320" y="3145536"/>
-            <a:ext cx="10058400" cy="603504"/>
+            <a:off x="1417320" y="2852928"/>
+            <a:ext cx="10058400" cy="548640"/>
           </a:xfrm>
           <a:prstGeom prst="rect">
             <a:avLst/>
@@ -7797,7 +7778,7 @@
               </a:spcAft>
             </a:pPr>
             <a:r>
-              <a:rPr sz="1200" b="0" i="0">
+              <a:rPr sz="1150" b="0" i="0">
                 <a:solidFill>
                   <a:srgbClr val="222A3A"/>
                 </a:solidFill>
@@ -7816,8 +7797,8 @@
         </p:nvSpPr>
         <p:spPr>
           <a:xfrm>
-            <a:off x="548640" y="3895344"/>
-            <a:ext cx="457200" cy="457200"/>
+            <a:off x="548640" y="3511296"/>
+            <a:ext cx="420624" cy="420624"/>
           </a:xfrm>
           <a:prstGeom prst="ellipse">
             <a:avLst/>
@@ -7850,7 +7831,7 @@
           <a:p>
             <a:pPr algn="ctr"/>
             <a:r>
-              <a:rPr sz="1600" b="1">
+              <a:rPr sz="1500" b="1">
                 <a:solidFill>
                   <a:srgbClr val="1E2761"/>
                 </a:solidFill>
@@ -7869,8 +7850,8 @@
         </p:nvSpPr>
         <p:spPr>
           <a:xfrm>
-            <a:off x="1188720" y="3895344"/>
-            <a:ext cx="10424160" cy="603504"/>
+            <a:off x="1188720" y="3511296"/>
+            <a:ext cx="10424160" cy="548640"/>
           </a:xfrm>
           <a:prstGeom prst="roundRect">
             <a:avLst/>
@@ -7915,8 +7896,8 @@
         </p:nvSpPr>
         <p:spPr>
           <a:xfrm>
-            <a:off x="1417320" y="3895344"/>
-            <a:ext cx="10058400" cy="603504"/>
+            <a:off x="1417320" y="3511296"/>
+            <a:ext cx="10058400" cy="548640"/>
           </a:xfrm>
           <a:prstGeom prst="rect">
             <a:avLst/>
@@ -7938,7 +7919,7 @@
               </a:spcAft>
             </a:pPr>
             <a:r>
-              <a:rPr sz="1200" b="0" i="0">
+              <a:rPr sz="1150" b="0" i="0">
                 <a:solidFill>
                   <a:srgbClr val="222A3A"/>
                 </a:solidFill>
@@ -7957,8 +7938,8 @@
         </p:nvSpPr>
         <p:spPr>
           <a:xfrm>
-            <a:off x="548640" y="4645152"/>
-            <a:ext cx="457200" cy="457200"/>
+            <a:off x="548640" y="4169663"/>
+            <a:ext cx="420624" cy="420624"/>
           </a:xfrm>
           <a:prstGeom prst="ellipse">
             <a:avLst/>
@@ -7991,7 +7972,7 @@
           <a:p>
             <a:pPr algn="ctr"/>
             <a:r>
-              <a:rPr sz="1600" b="1">
+              <a:rPr sz="1500" b="1">
                 <a:solidFill>
                   <a:srgbClr val="1E2761"/>
                 </a:solidFill>
@@ -8010,8 +7991,8 @@
         </p:nvSpPr>
         <p:spPr>
           <a:xfrm>
-            <a:off x="1188720" y="4645152"/>
-            <a:ext cx="10424160" cy="603504"/>
+            <a:off x="1188720" y="4169663"/>
+            <a:ext cx="10424160" cy="548640"/>
           </a:xfrm>
           <a:prstGeom prst="roundRect">
             <a:avLst/>
@@ -8056,8 +8037,8 @@
         </p:nvSpPr>
         <p:spPr>
           <a:xfrm>
-            <a:off x="1417320" y="4645152"/>
-            <a:ext cx="10058400" cy="603504"/>
+            <a:off x="1417320" y="4169663"/>
+            <a:ext cx="10058400" cy="548640"/>
           </a:xfrm>
           <a:prstGeom prst="rect">
             <a:avLst/>
@@ -8079,7 +8060,7 @@
               </a:spcAft>
             </a:pPr>
             <a:r>
-              <a:rPr sz="1200" b="0" i="0">
+              <a:rPr sz="1150" b="0" i="0">
                 <a:solidFill>
                   <a:srgbClr val="222A3A"/>
                 </a:solidFill>
@@ -8098,8 +8079,8 @@
         </p:nvSpPr>
         <p:spPr>
           <a:xfrm>
-            <a:off x="548640" y="5394959"/>
-            <a:ext cx="457200" cy="457200"/>
+            <a:off x="548640" y="4828031"/>
+            <a:ext cx="420624" cy="420624"/>
           </a:xfrm>
           <a:prstGeom prst="ellipse">
             <a:avLst/>
@@ -8132,7 +8113,7 @@
           <a:p>
             <a:pPr algn="ctr"/>
             <a:r>
-              <a:rPr sz="1600" b="1">
+              <a:rPr sz="1500" b="1">
                 <a:solidFill>
                   <a:srgbClr val="1E2761"/>
                 </a:solidFill>
@@ -8151,8 +8132,8 @@
         </p:nvSpPr>
         <p:spPr>
           <a:xfrm>
-            <a:off x="1188720" y="5394959"/>
-            <a:ext cx="10424160" cy="603504"/>
+            <a:off x="1188720" y="4828031"/>
+            <a:ext cx="10424160" cy="548640"/>
           </a:xfrm>
           <a:prstGeom prst="roundRect">
             <a:avLst/>
@@ -8197,8 +8178,8 @@
         </p:nvSpPr>
         <p:spPr>
           <a:xfrm>
-            <a:off x="1417320" y="5394959"/>
-            <a:ext cx="10058400" cy="603504"/>
+            <a:off x="1417320" y="4828031"/>
+            <a:ext cx="10058400" cy="548640"/>
           </a:xfrm>
           <a:prstGeom prst="rect">
             <a:avLst/>
@@ -8220,7 +8201,7 @@
               </a:spcAft>
             </a:pPr>
             <a:r>
-              <a:rPr sz="1200" b="0" i="0">
+              <a:rPr sz="1150" b="0" i="0">
                 <a:solidFill>
                   <a:srgbClr val="222A3A"/>
                 </a:solidFill>
@@ -11775,7 +11756,7 @@
                 </a:solidFill>
                 <a:latin typeface="Calibri"/>
               </a:rPr>
-              <a:t>~31 router · ~180 REST endpoint</a:t>
+              <a:t>32 router · ~379 REST endpoint</a:t>
             </a:r>
           </a:p>
         </p:txBody>
@@ -11903,7 +11884,7 @@
                 </a:solidFill>
                 <a:latin typeface="Calibri"/>
               </a:rPr>
-              <a:t>23 module quy tắc nghiệp vụ (batches, recipes, quality, bom…)</a:t>
+              <a:t>47 module quy tắc nghiệp vụ (batches, recipes, quality, bom, brew_order, filter_order, integration_connection…)</a:t>
             </a:r>
           </a:p>
         </p:txBody>
@@ -12031,7 +12012,7 @@
                 </a:solidFill>
                 <a:latin typeface="Calibri"/>
               </a:rPr>
-              <a:t>~40 bảng theo bounded context</a:t>
+              <a:t>~100 lớp theo bounded context</a:t>
             </a:r>
           </a:p>
         </p:txBody>
@@ -15396,7 +15377,7 @@
                 </a:solidFill>
                 <a:latin typeface="Cambria"/>
               </a:rPr>
-              <a:t>Mô hình dữ liệu (~40 bảng)</a:t>
+              <a:t>Mô hình dữ liệu (~100 lớp)</a:t>
             </a:r>
           </a:p>
         </p:txBody>
@@ -15656,7 +15637,7 @@
                 </a:solidFill>
                 <a:latin typeface="Calibri"/>
               </a:rPr>
-              <a:t>Product, Material, Line</a:t>
+              <a:t>Product, BeerType, FinishedProduct, Material, Supplier, Line</a:t>
             </a:r>
           </a:p>
         </p:txBody>
@@ -15744,7 +15725,7 @@
                 </a:solidFill>
                 <a:latin typeface="Calibri"/>
               </a:rPr>
-              <a:t>Lệnh &amp; điều độ</a:t>
+              <a:t>Lệnh nấu/lọc phân cấp</a:t>
             </a:r>
           </a:p>
         </p:txBody>
@@ -15786,7 +15767,7 @@
                 </a:solidFill>
                 <a:latin typeface="Calibri"/>
               </a:rPr>
-              <a:t>PO, WorkOrder, ScheduleSlot</a:t>
+              <a:t>BrewMasterOrder/Order, FilterMasterOrder/Order</a:t>
             </a:r>
           </a:p>
         </p:txBody>
@@ -16134,7 +16115,7 @@
                 </a:solidFill>
                 <a:latin typeface="Calibri"/>
               </a:rPr>
-              <a:t>Vật tư &amp; phả hệ</a:t>
+              <a:t>Nấu-Lọc-Chiết</a:t>
             </a:r>
           </a:p>
         </p:txBody>
@@ -16176,7 +16157,7 @@
                 </a:solidFill>
                 <a:latin typeface="Calibri"/>
               </a:rPr>
-              <a:t>Lot, GenealogyEdge, Dispense</a:t>
+              <a:t>BrewBatch, FermentRecord, FilterRecord, BottleRecord</a:t>
             </a:r>
           </a:p>
         </p:txBody>
@@ -16306,7 +16287,7 @@
                 </a:solidFill>
                 <a:latin typeface="Calibri"/>
               </a:rPr>
-              <a:t>QC Result, Deviation, CAPA, Sample</a:t>
+              <a:t>QC Result, Deviation, CAPA, Sample, QcGroup</a:t>
             </a:r>
           </a:p>
         </p:txBody>
@@ -16394,7 +16375,7 @@
                 </a:solidFill>
                 <a:latin typeface="Calibri"/>
               </a:rPr>
-              <a:t>Nấu-Lọc-Chiết</a:t>
+              <a:t>Kho NVL 2 địa điểm</a:t>
             </a:r>
           </a:p>
         </p:txBody>
@@ -16436,7 +16417,7 @@
                 </a:solidFill>
                 <a:latin typeface="Calibri"/>
               </a:rPr>
-              <a:t>Brew, Ferment, Filter, Bottle</a:t>
+              <a:t>MaterialLot, StockMovement, MaterialRequest, StockCount</a:t>
             </a:r>
           </a:p>
         </p:txBody>
@@ -16524,7 +16505,7 @@
                 </a:solidFill>
                 <a:latin typeface="Calibri"/>
               </a:rPr>
-              <a:t>Kho &amp; bao bì</a:t>
+              <a:t>WMS theo unit</a:t>
             </a:r>
           </a:p>
         </p:txBody>
@@ -16566,7 +16547,7 @@
                 </a:solidFill>
                 <a:latin typeface="Calibri"/>
               </a:rPr>
-              <a:t>StockMovement, Pallet, Case</a:t>
+              <a:t>FinishedGoodsUnit, Shipment, LoadSlip</a:t>
             </a:r>
           </a:p>
         </p:txBody>
@@ -16784,7 +16765,7 @@
                 </a:solidFill>
                 <a:latin typeface="Calibri"/>
               </a:rPr>
-              <a:t>Historian</a:t>
+              <a:t>Tích hợp CSDL ngoài</a:t>
             </a:r>
           </a:p>
         </p:txBody>
@@ -16826,7 +16807,7 @@
                 </a:solidFill>
                 <a:latin typeface="Calibri"/>
               </a:rPr>
-              <a:t>HistorianPoint (UNS tag)</a:t>
+              <a:t>SqlConnection, ImportProfile, custom field</a:t>
             </a:r>
           </a:p>
         </p:txBody>
@@ -19787,7 +19768,7 @@
                 </a:solidFill>
                 <a:latin typeface="Calibri"/>
               </a:rPr>
-              <a:t>19 quyền (require_perm)</a:t>
+              <a:t>21 quyền (require_perm)</a:t>
             </a:r>
           </a:p>
           <a:p>
@@ -19947,7 +19928,7 @@
                 </a:solidFill>
                 <a:latin typeface="Calibri"/>
               </a:rPr>
-              <a:t>SoD + data-scoping</a:t>
+              <a:t>SoD + data-scoping (4 chiều)</a:t>
             </a:r>
           </a:p>
         </p:txBody>
@@ -20027,7 +20008,26 @@
                 </a:solidFill>
                 <a:latin typeface="Calibri"/>
               </a:rPr>
-              <a:t>Scope theo line / khu vực / loại test</a:t>
+              <a:t>Scope: line / khu vực / loại test /</a:t>
+            </a:r>
+          </a:p>
+          <a:p>
+            <a:pPr algn="l">
+              <a:lnSpc>
+                <a:spcPct val="106000"/>
+              </a:lnSpc>
+              <a:spcAft>
+                <a:spcPts val="200"/>
+              </a:spcAft>
+            </a:pPr>
+            <a:r>
+              <a:rPr sz="1250" b="0" i="0">
+                <a:solidFill>
+                  <a:srgbClr val="222A3A"/>
+                </a:solidFill>
+                <a:latin typeface="Calibri"/>
+              </a:rPr>
+              <a:t>   địa điểm kho (cty ↔ phân xưởng)</a:t>
             </a:r>
           </a:p>
         </p:txBody>

</xml_diff>